<commit_message>
Polish premium UI and expand skills section.
Add categorized 12-skill layout with AI skill cards, refine header/navigation styling and card visuals, and include updated brochure/presentation files for the latest website content.

Made-with: Cursor
</commit_message>
<xml_diff>
--- a/Presentation/ppt/Pehchaan_Careers_English.pptx
+++ b/Presentation/ppt/Pehchaan_Careers_English.pptx
@@ -6458,7 +6458,7 @@
                 <a:ea typeface="Calibri" pitchFamily="34" charset="-122"/>
                 <a:cs typeface="Calibri" pitchFamily="34" charset="-120"/>
               </a:rPr>
-              <a:t>Whether your path is corporate, creative, govt, MBA or abroad — these 9 skills determine how far you go.</a:t>
+              <a:t>Whether your path is corporate, creative, govt, MBA or abroad — these 12 skills determine how far you go.</a:t>
             </a:r>
             <a:endParaRPr lang="en-US" sz="1300" dirty="0"/>
           </a:p>
@@ -6472,8 +6472,8 @@
         </p:nvSpPr>
         <p:spPr>
           <a:xfrm>
-            <a:off x="457200" y="1170432"/>
-            <a:ext cx="2651760" cy="804672"/>
+            <a:off x="457200" y="1117600"/>
+            <a:ext cx="2651760" cy="736600"/>
           </a:xfrm>
           <a:prstGeom prst="rect">
             <a:avLst/>
@@ -6497,8 +6497,8 @@
         </p:nvSpPr>
         <p:spPr>
           <a:xfrm>
-            <a:off x="457200" y="1170432"/>
-            <a:ext cx="73152" cy="804672"/>
+            <a:off x="457200" y="1117600"/>
+            <a:ext cx="73152" cy="736600"/>
           </a:xfrm>
           <a:prstGeom prst="rect">
             <a:avLst/>
@@ -6522,7 +6522,7 @@
         </p:nvSpPr>
         <p:spPr>
           <a:xfrm>
-            <a:off x="2761488" y="1225296"/>
+            <a:off x="2822904" y="1168400"/>
             <a:ext cx="274320" cy="182880"/>
           </a:xfrm>
           <a:prstGeom prst="rect">
@@ -6561,7 +6561,7 @@
         </p:nvSpPr>
         <p:spPr>
           <a:xfrm>
-            <a:off x="621792" y="1216152"/>
+            <a:off x="621792" y="1155700"/>
             <a:ext cx="2103120" cy="256032"/>
           </a:xfrm>
           <a:prstGeom prst="rect">
@@ -6600,7 +6600,7 @@
         </p:nvSpPr>
         <p:spPr>
           <a:xfrm>
-            <a:off x="621792" y="1490472"/>
+            <a:off x="621792" y="1422400"/>
             <a:ext cx="2395728" cy="438912"/>
           </a:xfrm>
           <a:prstGeom prst="rect">
@@ -6639,8 +6639,8 @@
         </p:nvSpPr>
         <p:spPr>
           <a:xfrm>
-            <a:off x="3355848" y="1170432"/>
-            <a:ext cx="2651760" cy="804672"/>
+            <a:off x="3355848" y="1117600"/>
+            <a:ext cx="2651760" cy="736600"/>
           </a:xfrm>
           <a:prstGeom prst="rect">
             <a:avLst/>
@@ -6664,8 +6664,8 @@
         </p:nvSpPr>
         <p:spPr>
           <a:xfrm>
-            <a:off x="3355848" y="1170432"/>
-            <a:ext cx="73152" cy="804672"/>
+            <a:off x="3355848" y="1117600"/>
+            <a:ext cx="73152" cy="736600"/>
           </a:xfrm>
           <a:prstGeom prst="rect">
             <a:avLst/>
@@ -6689,7 +6689,7 @@
         </p:nvSpPr>
         <p:spPr>
           <a:xfrm>
-            <a:off x="5660136" y="1225296"/>
+            <a:off x="5721552" y="1168400"/>
             <a:ext cx="274320" cy="182880"/>
           </a:xfrm>
           <a:prstGeom prst="rect">
@@ -6728,7 +6728,7 @@
         </p:nvSpPr>
         <p:spPr>
           <a:xfrm>
-            <a:off x="3520440" y="1216152"/>
+            <a:off x="3520440" y="1155700"/>
             <a:ext cx="2103120" cy="256032"/>
           </a:xfrm>
           <a:prstGeom prst="rect">
@@ -6767,7 +6767,7 @@
         </p:nvSpPr>
         <p:spPr>
           <a:xfrm>
-            <a:off x="3520440" y="1490472"/>
+            <a:off x="3520440" y="1422400"/>
             <a:ext cx="2395728" cy="438912"/>
           </a:xfrm>
           <a:prstGeom prst="rect">
@@ -6806,8 +6806,8 @@
         </p:nvSpPr>
         <p:spPr>
           <a:xfrm>
-            <a:off x="6254496" y="1170432"/>
-            <a:ext cx="2651760" cy="804672"/>
+            <a:off x="6254496" y="1117600"/>
+            <a:ext cx="2651760" cy="736600"/>
           </a:xfrm>
           <a:prstGeom prst="rect">
             <a:avLst/>
@@ -6831,8 +6831,8 @@
         </p:nvSpPr>
         <p:spPr>
           <a:xfrm>
-            <a:off x="6254496" y="1170432"/>
-            <a:ext cx="73152" cy="804672"/>
+            <a:off x="6254496" y="1117600"/>
+            <a:ext cx="73152" cy="736600"/>
           </a:xfrm>
           <a:prstGeom prst="rect">
             <a:avLst/>
@@ -6856,7 +6856,7 @@
         </p:nvSpPr>
         <p:spPr>
           <a:xfrm>
-            <a:off x="8558784" y="1225296"/>
+            <a:off x="8620200" y="1168400"/>
             <a:ext cx="274320" cy="182880"/>
           </a:xfrm>
           <a:prstGeom prst="rect">
@@ -6895,7 +6895,7 @@
         </p:nvSpPr>
         <p:spPr>
           <a:xfrm>
-            <a:off x="6419088" y="1216152"/>
+            <a:off x="6419088" y="1155700"/>
             <a:ext cx="2103120" cy="256032"/>
           </a:xfrm>
           <a:prstGeom prst="rect">
@@ -6934,7 +6934,7 @@
         </p:nvSpPr>
         <p:spPr>
           <a:xfrm>
-            <a:off x="6419088" y="1490472"/>
+            <a:off x="6419088" y="1422400"/>
             <a:ext cx="2395728" cy="438912"/>
           </a:xfrm>
           <a:prstGeom prst="rect">
@@ -6973,8 +6973,8 @@
         </p:nvSpPr>
         <p:spPr>
           <a:xfrm>
-            <a:off x="457200" y="2048256"/>
-            <a:ext cx="2651760" cy="804672"/>
+            <a:off x="457200" y="1943100"/>
+            <a:ext cx="2651760" cy="736600"/>
           </a:xfrm>
           <a:prstGeom prst="rect">
             <a:avLst/>
@@ -6998,8 +6998,8 @@
         </p:nvSpPr>
         <p:spPr>
           <a:xfrm>
-            <a:off x="457200" y="2048256"/>
-            <a:ext cx="73152" cy="804672"/>
+            <a:off x="457200" y="1943100"/>
+            <a:ext cx="73152" cy="736600"/>
           </a:xfrm>
           <a:prstGeom prst="rect">
             <a:avLst/>
@@ -7023,7 +7023,7 @@
         </p:nvSpPr>
         <p:spPr>
           <a:xfrm>
-            <a:off x="2761488" y="2103120"/>
+            <a:off x="2822904" y="1993900"/>
             <a:ext cx="274320" cy="182880"/>
           </a:xfrm>
           <a:prstGeom prst="rect">
@@ -7062,7 +7062,7 @@
         </p:nvSpPr>
         <p:spPr>
           <a:xfrm>
-            <a:off x="621792" y="2093976"/>
+            <a:off x="621792" y="1981200"/>
             <a:ext cx="2103120" cy="256032"/>
           </a:xfrm>
           <a:prstGeom prst="rect">
@@ -7101,7 +7101,7 @@
         </p:nvSpPr>
         <p:spPr>
           <a:xfrm>
-            <a:off x="621792" y="2368296"/>
+            <a:off x="621792" y="2247900"/>
             <a:ext cx="2395728" cy="438912"/>
           </a:xfrm>
           <a:prstGeom prst="rect">
@@ -7140,8 +7140,8 @@
         </p:nvSpPr>
         <p:spPr>
           <a:xfrm>
-            <a:off x="3355848" y="2048256"/>
-            <a:ext cx="2651760" cy="804672"/>
+            <a:off x="3355848" y="1943100"/>
+            <a:ext cx="2651760" cy="736600"/>
           </a:xfrm>
           <a:prstGeom prst="rect">
             <a:avLst/>
@@ -7165,8 +7165,8 @@
         </p:nvSpPr>
         <p:spPr>
           <a:xfrm>
-            <a:off x="3355848" y="2048256"/>
-            <a:ext cx="73152" cy="804672"/>
+            <a:off x="3355848" y="1943100"/>
+            <a:ext cx="73152" cy="736600"/>
           </a:xfrm>
           <a:prstGeom prst="rect">
             <a:avLst/>
@@ -7190,7 +7190,7 @@
         </p:nvSpPr>
         <p:spPr>
           <a:xfrm>
-            <a:off x="5660136" y="2103120"/>
+            <a:off x="5721552" y="1993900"/>
             <a:ext cx="274320" cy="182880"/>
           </a:xfrm>
           <a:prstGeom prst="rect">
@@ -7229,7 +7229,7 @@
         </p:nvSpPr>
         <p:spPr>
           <a:xfrm>
-            <a:off x="3520440" y="2093976"/>
+            <a:off x="3520440" y="1981200"/>
             <a:ext cx="2103120" cy="256032"/>
           </a:xfrm>
           <a:prstGeom prst="rect">
@@ -7268,7 +7268,7 @@
         </p:nvSpPr>
         <p:spPr>
           <a:xfrm>
-            <a:off x="3520440" y="2368296"/>
+            <a:off x="3520440" y="2247900"/>
             <a:ext cx="2395728" cy="438912"/>
           </a:xfrm>
           <a:prstGeom prst="rect">
@@ -7307,8 +7307,8 @@
         </p:nvSpPr>
         <p:spPr>
           <a:xfrm>
-            <a:off x="6254496" y="2048256"/>
-            <a:ext cx="2651760" cy="804672"/>
+            <a:off x="6254496" y="1943100"/>
+            <a:ext cx="2651760" cy="736600"/>
           </a:xfrm>
           <a:prstGeom prst="rect">
             <a:avLst/>
@@ -7332,8 +7332,8 @@
         </p:nvSpPr>
         <p:spPr>
           <a:xfrm>
-            <a:off x="6254496" y="2048256"/>
-            <a:ext cx="73152" cy="804672"/>
+            <a:off x="6254496" y="1943100"/>
+            <a:ext cx="73152" cy="736600"/>
           </a:xfrm>
           <a:prstGeom prst="rect">
             <a:avLst/>
@@ -7357,7 +7357,7 @@
         </p:nvSpPr>
         <p:spPr>
           <a:xfrm>
-            <a:off x="8558784" y="2103120"/>
+            <a:off x="8620200" y="1993900"/>
             <a:ext cx="274320" cy="182880"/>
           </a:xfrm>
           <a:prstGeom prst="rect">
@@ -7396,7 +7396,7 @@
         </p:nvSpPr>
         <p:spPr>
           <a:xfrm>
-            <a:off x="6419088" y="2093976"/>
+            <a:off x="6419088" y="1981200"/>
             <a:ext cx="2103120" cy="256032"/>
           </a:xfrm>
           <a:prstGeom prst="rect">
@@ -7435,7 +7435,7 @@
         </p:nvSpPr>
         <p:spPr>
           <a:xfrm>
-            <a:off x="6419088" y="2368296"/>
+            <a:off x="6419088" y="2247900"/>
             <a:ext cx="2395728" cy="438912"/>
           </a:xfrm>
           <a:prstGeom prst="rect">
@@ -7474,8 +7474,8 @@
         </p:nvSpPr>
         <p:spPr>
           <a:xfrm>
-            <a:off x="457200" y="2926080"/>
-            <a:ext cx="2651760" cy="804672"/>
+            <a:off x="457200" y="2768600"/>
+            <a:ext cx="2651760" cy="736600"/>
           </a:xfrm>
           <a:prstGeom prst="rect">
             <a:avLst/>
@@ -7499,8 +7499,8 @@
         </p:nvSpPr>
         <p:spPr>
           <a:xfrm>
-            <a:off x="457200" y="2926080"/>
-            <a:ext cx="73152" cy="804672"/>
+            <a:off x="457200" y="2768600"/>
+            <a:ext cx="73152" cy="736600"/>
           </a:xfrm>
           <a:prstGeom prst="rect">
             <a:avLst/>
@@ -7524,7 +7524,7 @@
         </p:nvSpPr>
         <p:spPr>
           <a:xfrm>
-            <a:off x="2761488" y="2980944"/>
+            <a:off x="2822904" y="2819400"/>
             <a:ext cx="274320" cy="182880"/>
           </a:xfrm>
           <a:prstGeom prst="rect">
@@ -7563,7 +7563,7 @@
         </p:nvSpPr>
         <p:spPr>
           <a:xfrm>
-            <a:off x="621792" y="2971800"/>
+            <a:off x="621792" y="2806700"/>
             <a:ext cx="2103120" cy="256032"/>
           </a:xfrm>
           <a:prstGeom prst="rect">
@@ -7602,7 +7602,7 @@
         </p:nvSpPr>
         <p:spPr>
           <a:xfrm>
-            <a:off x="621792" y="3246120"/>
+            <a:off x="621792" y="3073400"/>
             <a:ext cx="2395728" cy="438912"/>
           </a:xfrm>
           <a:prstGeom prst="rect">
@@ -7641,8 +7641,8 @@
         </p:nvSpPr>
         <p:spPr>
           <a:xfrm>
-            <a:off x="3355848" y="2926080"/>
-            <a:ext cx="2651760" cy="804672"/>
+            <a:off x="3355848" y="2768600"/>
+            <a:ext cx="2651760" cy="736600"/>
           </a:xfrm>
           <a:prstGeom prst="rect">
             <a:avLst/>
@@ -7666,8 +7666,8 @@
         </p:nvSpPr>
         <p:spPr>
           <a:xfrm>
-            <a:off x="3355848" y="2926080"/>
-            <a:ext cx="73152" cy="804672"/>
+            <a:off x="3355848" y="2768600"/>
+            <a:ext cx="73152" cy="736600"/>
           </a:xfrm>
           <a:prstGeom prst="rect">
             <a:avLst/>
@@ -7691,7 +7691,7 @@
         </p:nvSpPr>
         <p:spPr>
           <a:xfrm>
-            <a:off x="5660136" y="2980944"/>
+            <a:off x="5721552" y="2819400"/>
             <a:ext cx="274320" cy="182880"/>
           </a:xfrm>
           <a:prstGeom prst="rect">
@@ -7730,7 +7730,7 @@
         </p:nvSpPr>
         <p:spPr>
           <a:xfrm>
-            <a:off x="3520440" y="2971800"/>
+            <a:off x="3520440" y="2806700"/>
             <a:ext cx="2103120" cy="256032"/>
           </a:xfrm>
           <a:prstGeom prst="rect">
@@ -7769,7 +7769,7 @@
         </p:nvSpPr>
         <p:spPr>
           <a:xfrm>
-            <a:off x="3520440" y="3246120"/>
+            <a:off x="3520440" y="3073400"/>
             <a:ext cx="2395728" cy="438912"/>
           </a:xfrm>
           <a:prstGeom prst="rect">
@@ -7808,8 +7808,8 @@
         </p:nvSpPr>
         <p:spPr>
           <a:xfrm>
-            <a:off x="6254496" y="2926080"/>
-            <a:ext cx="2651760" cy="804672"/>
+            <a:off x="6254496" y="2768600"/>
+            <a:ext cx="2651760" cy="736600"/>
           </a:xfrm>
           <a:prstGeom prst="rect">
             <a:avLst/>
@@ -7833,8 +7833,8 @@
         </p:nvSpPr>
         <p:spPr>
           <a:xfrm>
-            <a:off x="6254496" y="2926080"/>
-            <a:ext cx="73152" cy="804672"/>
+            <a:off x="6254496" y="2768600"/>
+            <a:ext cx="73152" cy="736600"/>
           </a:xfrm>
           <a:prstGeom prst="rect">
             <a:avLst/>
@@ -7858,7 +7858,7 @@
         </p:nvSpPr>
         <p:spPr>
           <a:xfrm>
-            <a:off x="8558784" y="2980944"/>
+            <a:off x="8620200" y="2819400"/>
             <a:ext cx="274320" cy="182880"/>
           </a:xfrm>
           <a:prstGeom prst="rect">
@@ -7897,7 +7897,7 @@
         </p:nvSpPr>
         <p:spPr>
           <a:xfrm>
-            <a:off x="6419088" y="2971800"/>
+            <a:off x="6419088" y="2806700"/>
             <a:ext cx="2103120" cy="256032"/>
           </a:xfrm>
           <a:prstGeom prst="rect">
@@ -7936,7 +7936,7 @@
         </p:nvSpPr>
         <p:spPr>
           <a:xfrm>
-            <a:off x="6419088" y="3246120"/>
+            <a:off x="6419088" y="3073400"/>
             <a:ext cx="2395728" cy="438912"/>
           </a:xfrm>
           <a:prstGeom prst="rect">
@@ -7975,8 +7975,8 @@
         </p:nvSpPr>
         <p:spPr>
           <a:xfrm>
-            <a:off x="457200" y="4519753"/>
-            <a:ext cx="73152" cy="256032"/>
+            <a:off x="457200" y="4673600"/>
+            <a:ext cx="73152" cy="177800"/>
           </a:xfrm>
           <a:prstGeom prst="rect">
             <a:avLst/>
@@ -8000,8 +8000,8 @@
         </p:nvSpPr>
         <p:spPr>
           <a:xfrm>
-            <a:off x="594360" y="4519753"/>
-            <a:ext cx="1280160" cy="256032"/>
+            <a:off x="594360" y="4673600"/>
+            <a:ext cx="1280160" cy="177800"/>
           </a:xfrm>
           <a:prstGeom prst="rect">
             <a:avLst/>
@@ -8039,8 +8039,8 @@
         </p:nvSpPr>
         <p:spPr>
           <a:xfrm>
-            <a:off x="2103120" y="4519753"/>
-            <a:ext cx="73152" cy="256032"/>
+            <a:off x="2103120" y="4673600"/>
+            <a:ext cx="73152" cy="177800"/>
           </a:xfrm>
           <a:prstGeom prst="rect">
             <a:avLst/>
@@ -8064,8 +8064,8 @@
         </p:nvSpPr>
         <p:spPr>
           <a:xfrm>
-            <a:off x="2240280" y="4519753"/>
-            <a:ext cx="1463040" cy="256032"/>
+            <a:off x="2240280" y="4673600"/>
+            <a:ext cx="1463040" cy="177800"/>
           </a:xfrm>
           <a:prstGeom prst="rect">
             <a:avLst/>
@@ -8103,8 +8103,8 @@
         </p:nvSpPr>
         <p:spPr>
           <a:xfrm>
-            <a:off x="3931920" y="4519753"/>
-            <a:ext cx="73152" cy="256032"/>
+            <a:off x="3931920" y="4673600"/>
+            <a:ext cx="73152" cy="177800"/>
           </a:xfrm>
           <a:prstGeom prst="rect">
             <a:avLst/>
@@ -8128,8 +8128,8 @@
         </p:nvSpPr>
         <p:spPr>
           <a:xfrm>
-            <a:off x="4069080" y="4519753"/>
-            <a:ext cx="1097280" cy="256032"/>
+            <a:off x="4069080" y="4673600"/>
+            <a:ext cx="1097280" cy="177800"/>
           </a:xfrm>
           <a:prstGeom prst="rect">
             <a:avLst/>
@@ -8167,8 +8167,8 @@
         </p:nvSpPr>
         <p:spPr>
           <a:xfrm>
-            <a:off x="457200" y="4011165"/>
-            <a:ext cx="8449056" cy="347472"/>
+            <a:off x="457200" y="4356100"/>
+            <a:ext cx="8449056" cy="292100"/>
           </a:xfrm>
           <a:prstGeom prst="rect">
             <a:avLst/>
@@ -8192,8 +8192,8 @@
         </p:nvSpPr>
         <p:spPr>
           <a:xfrm>
-            <a:off x="640080" y="4038597"/>
-            <a:ext cx="7863840" cy="292608"/>
+            <a:off x="640080" y="4368800"/>
+            <a:ext cx="7863840" cy="266700"/>
           </a:xfrm>
           <a:prstGeom prst="rect">
             <a:avLst/>
@@ -8341,6 +8341,560 @@
               <a:t>Pehchaancareers.in</a:t>
             </a:r>
             <a:endParaRPr lang="en-US" sz="900" dirty="0"/>
+          </a:p>
+        </p:txBody>
+      </p:sp>
+      <p:sp>
+        <p:nvSpPr>
+          <p:cNvPr id="100" name="AIShape100"/>
+          <p:cNvSpPr/>
+          <p:nvPr/>
+        </p:nvSpPr>
+        <p:spPr>
+          <a:xfrm>
+            <a:off x="457200" y="3594100"/>
+            <a:ext cx="2651760" cy="736600"/>
+          </a:xfrm>
+          <a:prstGeom prst="rect">
+            <a:avLst/>
+          </a:prstGeom>
+          <a:solidFill>
+            <a:srgbClr val="F8FAFC"/>
+          </a:solidFill>
+          <a:ln w="12700">
+            <a:solidFill>
+              <a:srgbClr val="E2E8F0"/>
+            </a:solidFill>
+            <a:prstDash val="solid"/>
+          </a:ln>
+        </p:spPr>
+      </p:sp>
+      <p:sp>
+        <p:nvSpPr>
+          <p:cNvPr id="101" name="AIAccent101"/>
+          <p:cNvSpPr/>
+          <p:nvPr/>
+        </p:nvSpPr>
+        <p:spPr>
+          <a:xfrm>
+            <a:off x="457200" y="3594100"/>
+            <a:ext cx="73152" cy="736600"/>
+          </a:xfrm>
+          <a:prstGeom prst="rect">
+            <a:avLst/>
+          </a:prstGeom>
+          <a:solidFill>
+            <a:srgbClr val="1A1A2E"/>
+          </a:solidFill>
+          <a:ln w="12700">
+            <a:solidFill>
+              <a:srgbClr val="1A1A2E"/>
+            </a:solidFill>
+            <a:prstDash val="solid"/>
+          </a:ln>
+        </p:spPr>
+      </p:sp>
+      <p:sp>
+        <p:nvSpPr>
+          <p:cNvPr id="102" name="AINum102"/>
+          <p:cNvSpPr/>
+          <p:nvPr/>
+        </p:nvSpPr>
+        <p:spPr>
+          <a:xfrm>
+            <a:off x="2798064" y="3644900"/>
+            <a:ext cx="324000" cy="182880"/>
+          </a:xfrm>
+          <a:prstGeom prst="rect">
+            <a:avLst/>
+          </a:prstGeom>
+          <a:noFill/>
+          <a:ln/>
+        </p:spPr>
+        <p:txBody>
+          <a:bodyPr wrap="square" rtlCol="0" anchor="ctr"/>
+          <a:lstStyle/>
+          <a:p>
+            <a:pPr marL="0" indent="0" algn="r">
+              <a:buNone/>
+            </a:pPr>
+            <a:r>
+              <a:rPr lang="en-US" sz="900" b="1" dirty="0">
+                <a:solidFill>
+                  <a:srgbClr val="1A1A2E"/>
+                </a:solidFill>
+                <a:latin typeface="Calibri" pitchFamily="34" charset="0"/>
+              </a:rPr>
+              <a:t>10</a:t>
+            </a:r>
+          </a:p>
+        </p:txBody>
+      </p:sp>
+      <p:sp>
+        <p:nvSpPr>
+          <p:cNvPr id="103" name="AIName103"/>
+          <p:cNvSpPr/>
+          <p:nvPr/>
+        </p:nvSpPr>
+        <p:spPr>
+          <a:xfrm>
+            <a:off x="621552" y="3632200"/>
+            <a:ext cx="2103120" cy="256032"/>
+          </a:xfrm>
+          <a:prstGeom prst="rect">
+            <a:avLst/>
+          </a:prstGeom>
+          <a:noFill/>
+          <a:ln/>
+        </p:spPr>
+        <p:txBody>
+          <a:bodyPr wrap="square" rtlCol="0" anchor="ctr"/>
+          <a:lstStyle/>
+          <a:p>
+            <a:pPr marL="0" indent="0">
+              <a:buNone/>
+            </a:pPr>
+            <a:r>
+              <a:rPr lang="en-US" sz="1300" b="1" dirty="0">
+                <a:solidFill>
+                  <a:srgbClr val="1A1A2E"/>
+                </a:solidFill>
+                <a:latin typeface="Calibri" pitchFamily="34" charset="0"/>
+              </a:rPr>
+              <a:t>AI Tools Literacy</a:t>
+            </a:r>
+          </a:p>
+        </p:txBody>
+      </p:sp>
+      <p:sp>
+        <p:nvSpPr>
+          <p:cNvPr id="104" name="AIDesc104"/>
+          <p:cNvSpPr/>
+          <p:nvPr/>
+        </p:nvSpPr>
+        <p:spPr>
+          <a:xfrm>
+            <a:off x="621552" y="3898900"/>
+            <a:ext cx="2395728" cy="438912"/>
+          </a:xfrm>
+          <a:prstGeom prst="rect">
+            <a:avLst/>
+          </a:prstGeom>
+          <a:noFill/>
+          <a:ln/>
+        </p:spPr>
+        <p:txBody>
+          <a:bodyPr wrap="square" rtlCol="0" anchor="t"/>
+          <a:lstStyle/>
+          <a:p>
+            <a:pPr marL="0" indent="0">
+              <a:buNone/>
+            </a:pPr>
+            <a:r>
+              <a:rPr lang="en-US" sz="1050" dirty="0">
+                <a:solidFill>
+                  <a:srgbClr val="64748B"/>
+                </a:solidFill>
+                <a:latin typeface="Calibri" pitchFamily="34" charset="0"/>
+              </a:rPr>
+              <a:t>Using tools like ChatGPT, Gemini, Canva AI to work faster</a:t>
+            </a:r>
+          </a:p>
+        </p:txBody>
+      </p:sp>
+      <p:sp>
+        <p:nvSpPr>
+          <p:cNvPr id="110" name="AIShape110"/>
+          <p:cNvSpPr/>
+          <p:nvPr/>
+        </p:nvSpPr>
+        <p:spPr>
+          <a:xfrm>
+            <a:off x="3355848" y="3594100"/>
+            <a:ext cx="2651760" cy="736600"/>
+          </a:xfrm>
+          <a:prstGeom prst="rect">
+            <a:avLst/>
+          </a:prstGeom>
+          <a:solidFill>
+            <a:srgbClr val="F8FAFC"/>
+          </a:solidFill>
+          <a:ln w="12700">
+            <a:solidFill>
+              <a:srgbClr val="E2E8F0"/>
+            </a:solidFill>
+            <a:prstDash val="solid"/>
+          </a:ln>
+        </p:spPr>
+      </p:sp>
+      <p:sp>
+        <p:nvSpPr>
+          <p:cNvPr id="111" name="AIAccent111"/>
+          <p:cNvSpPr/>
+          <p:nvPr/>
+        </p:nvSpPr>
+        <p:spPr>
+          <a:xfrm>
+            <a:off x="3355848" y="3594100"/>
+            <a:ext cx="73152" cy="736600"/>
+          </a:xfrm>
+          <a:prstGeom prst="rect">
+            <a:avLst/>
+          </a:prstGeom>
+          <a:solidFill>
+            <a:srgbClr val="1A1A2E"/>
+          </a:solidFill>
+          <a:ln w="12700">
+            <a:solidFill>
+              <a:srgbClr val="1A1A2E"/>
+            </a:solidFill>
+            <a:prstDash val="solid"/>
+          </a:ln>
+        </p:spPr>
+      </p:sp>
+      <p:sp>
+        <p:nvSpPr>
+          <p:cNvPr id="112" name="AINum112"/>
+          <p:cNvSpPr/>
+          <p:nvPr/>
+        </p:nvSpPr>
+        <p:spPr>
+          <a:xfrm>
+            <a:off x="5696712" y="3644900"/>
+            <a:ext cx="324000" cy="182880"/>
+          </a:xfrm>
+          <a:prstGeom prst="rect">
+            <a:avLst/>
+          </a:prstGeom>
+          <a:noFill/>
+          <a:ln/>
+        </p:spPr>
+        <p:txBody>
+          <a:bodyPr wrap="square" rtlCol="0" anchor="ctr"/>
+          <a:lstStyle/>
+          <a:p>
+            <a:pPr marL="0" indent="0" algn="r">
+              <a:buNone/>
+            </a:pPr>
+            <a:r>
+              <a:rPr lang="en-US" sz="900" b="1" dirty="0">
+                <a:solidFill>
+                  <a:srgbClr val="1A1A2E"/>
+                </a:solidFill>
+                <a:latin typeface="Calibri" pitchFamily="34" charset="0"/>
+              </a:rPr>
+              <a:t>11</a:t>
+            </a:r>
+          </a:p>
+        </p:txBody>
+      </p:sp>
+      <p:sp>
+        <p:nvSpPr>
+          <p:cNvPr id="113" name="AIName113"/>
+          <p:cNvSpPr/>
+          <p:nvPr/>
+        </p:nvSpPr>
+        <p:spPr>
+          <a:xfrm>
+            <a:off x="3520200" y="3632200"/>
+            <a:ext cx="2103120" cy="256032"/>
+          </a:xfrm>
+          <a:prstGeom prst="rect">
+            <a:avLst/>
+          </a:prstGeom>
+          <a:noFill/>
+          <a:ln/>
+        </p:spPr>
+        <p:txBody>
+          <a:bodyPr wrap="square" rtlCol="0" anchor="ctr"/>
+          <a:lstStyle/>
+          <a:p>
+            <a:pPr marL="0" indent="0">
+              <a:buNone/>
+            </a:pPr>
+            <a:r>
+              <a:rPr lang="en-US" sz="1300" b="1" dirty="0">
+                <a:solidFill>
+                  <a:srgbClr val="1A1A2E"/>
+                </a:solidFill>
+                <a:latin typeface="Calibri" pitchFamily="34" charset="0"/>
+              </a:rPr>
+              <a:t>Prompt Thinking</a:t>
+            </a:r>
+          </a:p>
+        </p:txBody>
+      </p:sp>
+      <p:sp>
+        <p:nvSpPr>
+          <p:cNvPr id="114" name="AIDesc114"/>
+          <p:cNvSpPr/>
+          <p:nvPr/>
+        </p:nvSpPr>
+        <p:spPr>
+          <a:xfrm>
+            <a:off x="3520200" y="3898900"/>
+            <a:ext cx="2395728" cy="438912"/>
+          </a:xfrm>
+          <a:prstGeom prst="rect">
+            <a:avLst/>
+          </a:prstGeom>
+          <a:noFill/>
+          <a:ln/>
+        </p:spPr>
+        <p:txBody>
+          <a:bodyPr wrap="square" rtlCol="0" anchor="t"/>
+          <a:lstStyle/>
+          <a:p>
+            <a:pPr marL="0" indent="0">
+              <a:buNone/>
+            </a:pPr>
+            <a:r>
+              <a:rPr lang="en-US" sz="1050" dirty="0">
+                <a:solidFill>
+                  <a:srgbClr val="64748B"/>
+                </a:solidFill>
+                <a:latin typeface="Calibri" pitchFamily="34" charset="0"/>
+              </a:rPr>
+              <a:t>Knowing how to ask the right question to get the right output.</a:t>
+            </a:r>
+          </a:p>
+        </p:txBody>
+      </p:sp>
+      <p:sp>
+        <p:nvSpPr>
+          <p:cNvPr id="120" name="AIShape120"/>
+          <p:cNvSpPr/>
+          <p:nvPr/>
+        </p:nvSpPr>
+        <p:spPr>
+          <a:xfrm>
+            <a:off x="6254496" y="3594100"/>
+            <a:ext cx="2651760" cy="736600"/>
+          </a:xfrm>
+          <a:prstGeom prst="rect">
+            <a:avLst/>
+          </a:prstGeom>
+          <a:solidFill>
+            <a:srgbClr val="F8FAFC"/>
+          </a:solidFill>
+          <a:ln w="12700">
+            <a:solidFill>
+              <a:srgbClr val="E2E8F0"/>
+            </a:solidFill>
+            <a:prstDash val="solid"/>
+          </a:ln>
+        </p:spPr>
+      </p:sp>
+      <p:sp>
+        <p:nvSpPr>
+          <p:cNvPr id="121" name="AIAccent121"/>
+          <p:cNvSpPr/>
+          <p:nvPr/>
+        </p:nvSpPr>
+        <p:spPr>
+          <a:xfrm>
+            <a:off x="6254496" y="3594100"/>
+            <a:ext cx="73152" cy="736600"/>
+          </a:xfrm>
+          <a:prstGeom prst="rect">
+            <a:avLst/>
+          </a:prstGeom>
+          <a:solidFill>
+            <a:srgbClr val="1A1A2E"/>
+          </a:solidFill>
+          <a:ln w="12700">
+            <a:solidFill>
+              <a:srgbClr val="1A1A2E"/>
+            </a:solidFill>
+            <a:prstDash val="solid"/>
+          </a:ln>
+        </p:spPr>
+      </p:sp>
+      <p:sp>
+        <p:nvSpPr>
+          <p:cNvPr id="122" name="AINum122"/>
+          <p:cNvSpPr/>
+          <p:nvPr/>
+        </p:nvSpPr>
+        <p:spPr>
+          <a:xfrm>
+            <a:off x="8595360" y="3644900"/>
+            <a:ext cx="324000" cy="182880"/>
+          </a:xfrm>
+          <a:prstGeom prst="rect">
+            <a:avLst/>
+          </a:prstGeom>
+          <a:noFill/>
+          <a:ln/>
+        </p:spPr>
+        <p:txBody>
+          <a:bodyPr wrap="square" rtlCol="0" anchor="ctr"/>
+          <a:lstStyle/>
+          <a:p>
+            <a:pPr marL="0" indent="0" algn="r">
+              <a:buNone/>
+            </a:pPr>
+            <a:r>
+              <a:rPr lang="en-US" sz="900" b="1" dirty="0">
+                <a:solidFill>
+                  <a:srgbClr val="1A1A2E"/>
+                </a:solidFill>
+                <a:latin typeface="Calibri" pitchFamily="34" charset="0"/>
+              </a:rPr>
+              <a:t>12</a:t>
+            </a:r>
+          </a:p>
+        </p:txBody>
+      </p:sp>
+      <p:sp>
+        <p:nvSpPr>
+          <p:cNvPr id="123" name="AIName123"/>
+          <p:cNvSpPr/>
+          <p:nvPr/>
+        </p:nvSpPr>
+        <p:spPr>
+          <a:xfrm>
+            <a:off x="6418848" y="3632200"/>
+            <a:ext cx="2103120" cy="256032"/>
+          </a:xfrm>
+          <a:prstGeom prst="rect">
+            <a:avLst/>
+          </a:prstGeom>
+          <a:noFill/>
+          <a:ln/>
+        </p:spPr>
+        <p:txBody>
+          <a:bodyPr wrap="square" rtlCol="0" anchor="ctr"/>
+          <a:lstStyle/>
+          <a:p>
+            <a:pPr marL="0" indent="0">
+              <a:buNone/>
+            </a:pPr>
+            <a:r>
+              <a:rPr lang="en-US" sz="1300" b="1" dirty="0">
+                <a:solidFill>
+                  <a:srgbClr val="1A1A2E"/>
+                </a:solidFill>
+                <a:latin typeface="Calibri" pitchFamily="34" charset="0"/>
+              </a:rPr>
+              <a:t>Human + AI Judgment</a:t>
+            </a:r>
+          </a:p>
+        </p:txBody>
+      </p:sp>
+      <p:sp>
+        <p:nvSpPr>
+          <p:cNvPr id="124" name="AIDesc124"/>
+          <p:cNvSpPr/>
+          <p:nvPr/>
+        </p:nvSpPr>
+        <p:spPr>
+          <a:xfrm>
+            <a:off x="6418848" y="3898900"/>
+            <a:ext cx="2395728" cy="438912"/>
+          </a:xfrm>
+          <a:prstGeom prst="rect">
+            <a:avLst/>
+          </a:prstGeom>
+          <a:noFill/>
+          <a:ln/>
+        </p:spPr>
+        <p:txBody>
+          <a:bodyPr wrap="square" rtlCol="0" anchor="t"/>
+          <a:lstStyle/>
+          <a:p>
+            <a:pPr marL="0" indent="0">
+              <a:buNone/>
+            </a:pPr>
+            <a:r>
+              <a:rPr lang="en-US" sz="1050" dirty="0">
+                <a:solidFill>
+                  <a:srgbClr val="64748B"/>
+                </a:solidFill>
+                <a:latin typeface="Calibri" pitchFamily="34" charset="0"/>
+              </a:rPr>
+              <a:t>Understanding when to trust AI and when to think for yourself.</a:t>
+            </a:r>
+          </a:p>
+        </p:txBody>
+      </p:sp>
+      <p:sp>
+        <p:nvSpPr>
+          <p:cNvPr id="61" name="Shape 51">
+            <a:extLst>
+              <a:ext uri="{FF2B5EF4-FFF2-40B4-BE49-F238E27FC236}">
+                <a16:creationId xmlns:a16="http://schemas.microsoft.com/office/drawing/2014/main" id="{C0A924B3-AD72-6893-071C-4D8232C9963E}"/>
+              </a:ext>
+            </a:extLst>
+          </p:cNvPr>
+          <p:cNvSpPr/>
+          <p:nvPr/>
+        </p:nvSpPr>
+        <p:spPr>
+          <a:xfrm>
+            <a:off x="5230368" y="4673600"/>
+            <a:ext cx="73152" cy="177800"/>
+          </a:xfrm>
+          <a:prstGeom prst="rect">
+            <a:avLst/>
+          </a:prstGeom>
+          <a:solidFill>
+            <a:srgbClr val="1A1A2E"/>
+          </a:solidFill>
+          <a:ln w="12700">
+            <a:solidFill>
+              <a:srgbClr val="1A1A2E"/>
+            </a:solidFill>
+            <a:prstDash val="solid"/>
+          </a:ln>
+        </p:spPr>
+      </p:sp>
+      <p:sp>
+        <p:nvSpPr>
+          <p:cNvPr id="62" name="Text 52">
+            <a:extLst>
+              <a:ext uri="{FF2B5EF4-FFF2-40B4-BE49-F238E27FC236}">
+                <a16:creationId xmlns:a16="http://schemas.microsoft.com/office/drawing/2014/main" id="{AE631447-6E26-4B10-ADE0-973E0DF53DF6}"/>
+              </a:ext>
+            </a:extLst>
+          </p:cNvPr>
+          <p:cNvSpPr/>
+          <p:nvPr/>
+        </p:nvSpPr>
+        <p:spPr>
+          <a:xfrm>
+            <a:off x="5367528" y="4673600"/>
+            <a:ext cx="1097280" cy="177800"/>
+          </a:xfrm>
+          <a:prstGeom prst="rect">
+            <a:avLst/>
+          </a:prstGeom>
+          <a:noFill/>
+          <a:ln/>
+        </p:spPr>
+        <p:txBody>
+          <a:bodyPr wrap="square" rtlCol="0" anchor="ctr"/>
+          <a:lstStyle/>
+          <a:p>
+            <a:pPr marL="0" indent="0">
+              <a:buNone/>
+            </a:pPr>
+            <a:r>
+              <a:rPr lang="en-US" sz="1000" b="1" dirty="0">
+                <a:solidFill>
+                  <a:srgbClr val="1A1A2E"/>
+                </a:solidFill>
+                <a:latin typeface="Calibri" pitchFamily="34" charset="0"/>
+                <a:ea typeface="Calibri" pitchFamily="34" charset="-122"/>
+                <a:cs typeface="Calibri" pitchFamily="34" charset="-120"/>
+              </a:rPr>
+              <a:t>AI Knowledge</a:t>
+            </a:r>
+            <a:endParaRPr lang="en-US" sz="1000" dirty="0">
+              <a:solidFill>
+                <a:srgbClr val="1A1A2E"/>
+              </a:solidFill>
+            </a:endParaRPr>
           </a:p>
         </p:txBody>
       </p:sp>
@@ -13497,4 +14051,26 @@
     </a:ext>
   </a:extLst>
 </a:theme>
+</file>
+
+<file path=ppt/webextensions/taskpanes.xml><?xml version="1.0" encoding="utf-8"?>
+<wetp:taskpanes xmlns:wetp="http://schemas.microsoft.com/office/webextensions/taskpanes/2010/11">
+  <wetp:taskpane dockstate="right" visibility="0" width="531" row="6">
+    <wetp:webextensionref xmlns:r="http://schemas.openxmlformats.org/officeDocument/2006/relationships" r:id="rId1"/>
+  </wetp:taskpane>
+</wetp:taskpanes>
+</file>
+
+<file path=ppt/webextensions/webextension1.xml><?xml version="1.0" encoding="utf-8"?>
+<we:webextension xmlns:we="http://schemas.microsoft.com/office/webextensions/webextension/2010/11" id="{94D9409C-3CFB-4140-9242-33BDC030FEF1}">
+  <we:reference id="wa200010001" version="1.0.0.1" store="en-US" storeType="OMEX"/>
+  <we:alternateReferences>
+    <we:reference id="wa200010001" version="1.0.0.1" store="WA200010001" storeType="OMEX"/>
+  </we:alternateReferences>
+  <we:properties>
+    <we:property name="claude.fileId" value="&quot;0353ad17-783f-4080-a4cf-269d281acd4d&quot;"/>
+  </we:properties>
+  <we:bindings/>
+  <we:snapshot xmlns:r="http://schemas.openxmlformats.org/officeDocument/2006/relationships"/>
+</we:webextension>
 </file>
</xml_diff>